<commit_message>
feat: PromptForge v1.2 creative deck + design doc, second task, IAOV protocol
</commit_message>
<xml_diff>
--- a/docs/PromptForge_Creative_PPT_v1.2.pptx
+++ b/docs/PromptForge_Creative_PPT_v1.2.pptx
@@ -15070,14 +15070,14 @@
               <a:t>口径：</a:t>
             </a:r>
             <a:r>
-              <a:rPr sz="800" b="0">
+              <a:rPr sz="780" b="0">
                 <a:solidFill>
                   <a:srgbClr val="595959"/>
                 </a:solidFill>
                 <a:latin typeface="Microsoft YaHei"/>
                 <a:ea typeface="Microsoft YaHei"/>
               </a:rPr>
-              <a:t>v0.1 为单任务、单模型 A/B + 规则/测试决策，结论用于演示，不宣称统计显著；异构评委与完整机机联动为设计目标。</a:t>
+              <a:t>任务一为单任务/单模型 A/B；第二个任务已复现（A 4/6、B 6/6，2026-10-31）；不宣称统计显著；异构评委与完整机机联动为设计目标。</a:t>
             </a:r>
           </a:p>
         </p:txBody>

</xml_diff>